<commit_message>
slide: căn chỉnh toàn bộ hình ảnh và bảng số liệu nằm gọn trong khung thẻ các slide 5 7 8 9 10 12
</commit_message>
<xml_diff>
--- a/reports/presentation/Nhom12_BaoCao_Slides.pptx
+++ b/reports/presentation/Nhom12_BaoCao_Slides.pptx
@@ -5359,9 +5359,54 @@
           </a:p>
         </p:txBody>
       </p:sp>
+      <p:sp>
+        <p:nvSpPr>
+          <p:cNvPr id="6" name="Rounded Rectangle 5"/>
+          <p:cNvSpPr/>
+          <p:nvPr/>
+        </p:nvSpPr>
+        <p:spPr>
+          <a:xfrm>
+            <a:off x="4297680" y="1463040"/>
+            <a:ext cx="7162495" cy="4846320"/>
+          </a:xfrm>
+          <a:prstGeom prst="roundRect">
+            <a:avLst/>
+          </a:prstGeom>
+          <a:solidFill>
+            <a:srgbClr val="FFFFFF"/>
+          </a:solidFill>
+          <a:ln w="19050">
+            <a:solidFill>
+              <a:srgbClr val="059669"/>
+            </a:solidFill>
+          </a:ln>
+        </p:spPr>
+        <p:style>
+          <a:lnRef idx="1">
+            <a:schemeClr val="accent1"/>
+          </a:lnRef>
+          <a:fillRef idx="3">
+            <a:schemeClr val="accent1"/>
+          </a:fillRef>
+          <a:effectRef idx="2">
+            <a:schemeClr val="accent1"/>
+          </a:effectRef>
+          <a:fontRef idx="minor">
+            <a:schemeClr val="lt1"/>
+          </a:fontRef>
+        </p:style>
+        <p:txBody>
+          <a:bodyPr rtlCol="0" anchor="ctr"/>
+          <a:lstStyle/>
+          <a:p>
+            <a:pPr algn="ctr"/>
+          </a:p>
+        </p:txBody>
+      </p:sp>
       <p:pic>
         <p:nvPicPr>
-          <p:cNvPr id="6" name="Picture 5" descr="excel_stability_ari.png"/>
+          <p:cNvPr id="7" name="Picture 6" descr="excel_stability_ari.png"/>
           <p:cNvPicPr>
             <a:picLocks noChangeAspect="1"/>
           </p:cNvPicPr>
@@ -5375,8 +5420,8 @@
         </p:blipFill>
         <p:spPr>
           <a:xfrm>
-            <a:off x="4297680" y="1463040"/>
-            <a:ext cx="7162495" cy="4638568"/>
+            <a:off x="4443984" y="1661665"/>
+            <a:ext cx="6869887" cy="4449069"/>
           </a:xfrm>
           <a:prstGeom prst="rect">
             <a:avLst/>
@@ -5799,9 +5844,54 @@
           </a:p>
         </p:txBody>
       </p:sp>
+      <p:sp>
+        <p:nvSpPr>
+          <p:cNvPr id="10" name="Rounded Rectangle 9"/>
+          <p:cNvSpPr/>
+          <p:nvPr/>
+        </p:nvSpPr>
+        <p:spPr>
+          <a:xfrm>
+            <a:off x="5760720" y="1463040"/>
+            <a:ext cx="5699455" cy="4846320"/>
+          </a:xfrm>
+          <a:prstGeom prst="roundRect">
+            <a:avLst/>
+          </a:prstGeom>
+          <a:solidFill>
+            <a:srgbClr val="FFFFFF"/>
+          </a:solidFill>
+          <a:ln w="19050">
+            <a:solidFill>
+              <a:srgbClr val="E2E8F0"/>
+            </a:solidFill>
+          </a:ln>
+        </p:spPr>
+        <p:style>
+          <a:lnRef idx="1">
+            <a:schemeClr val="accent1"/>
+          </a:lnRef>
+          <a:fillRef idx="3">
+            <a:schemeClr val="accent1"/>
+          </a:fillRef>
+          <a:effectRef idx="2">
+            <a:schemeClr val="accent1"/>
+          </a:effectRef>
+          <a:fontRef idx="minor">
+            <a:schemeClr val="lt1"/>
+          </a:fontRef>
+        </p:style>
+        <p:txBody>
+          <a:bodyPr rtlCol="0" anchor="ctr"/>
+          <a:lstStyle/>
+          <a:p>
+            <a:pPr algn="ctr"/>
+          </a:p>
+        </p:txBody>
+      </p:sp>
       <p:pic>
         <p:nvPicPr>
-          <p:cNvPr id="10" name="Picture 9" descr="radar_chart_2019.png"/>
+          <p:cNvPr id="11" name="Picture 10" descr="radar_chart_2019.png"/>
           <p:cNvPicPr>
             <a:picLocks noChangeAspect="1"/>
           </p:cNvPicPr>
@@ -5815,8 +5905,8 @@
         </p:blipFill>
         <p:spPr>
           <a:xfrm>
-            <a:off x="5760720" y="1463040"/>
-            <a:ext cx="5699455" cy="3264233"/>
+            <a:off x="5897879" y="2332638"/>
+            <a:ext cx="5425135" cy="3107122"/>
           </a:xfrm>
           <a:prstGeom prst="rect">
             <a:avLst/>
@@ -6153,9 +6243,54 @@
           </a:p>
         </p:txBody>
       </p:sp>
+      <p:sp>
+        <p:nvSpPr>
+          <p:cNvPr id="6" name="Rounded Rectangle 5"/>
+          <p:cNvSpPr/>
+          <p:nvPr/>
+        </p:nvSpPr>
+        <p:spPr>
+          <a:xfrm>
+            <a:off x="6035040" y="1463040"/>
+            <a:ext cx="5425135" cy="4846320"/>
+          </a:xfrm>
+          <a:prstGeom prst="roundRect">
+            <a:avLst/>
+          </a:prstGeom>
+          <a:solidFill>
+            <a:srgbClr val="FFFFFF"/>
+          </a:solidFill>
+          <a:ln w="19050">
+            <a:solidFill>
+              <a:srgbClr val="D97706"/>
+            </a:solidFill>
+          </a:ln>
+        </p:spPr>
+        <p:style>
+          <a:lnRef idx="1">
+            <a:schemeClr val="accent1"/>
+          </a:lnRef>
+          <a:fillRef idx="3">
+            <a:schemeClr val="accent1"/>
+          </a:fillRef>
+          <a:effectRef idx="2">
+            <a:schemeClr val="accent1"/>
+          </a:effectRef>
+          <a:fontRef idx="minor">
+            <a:schemeClr val="lt1"/>
+          </a:fontRef>
+        </p:style>
+        <p:txBody>
+          <a:bodyPr rtlCol="0" anchor="ctr"/>
+          <a:lstStyle/>
+          <a:p>
+            <a:pPr algn="ctr"/>
+          </a:p>
+        </p:txBody>
+      </p:sp>
       <p:pic>
         <p:nvPicPr>
-          <p:cNvPr id="6" name="Picture 5" descr="validation_happiness_score_2019.png"/>
+          <p:cNvPr id="7" name="Picture 6" descr="validation_happiness_score_2019.png"/>
           <p:cNvPicPr>
             <a:picLocks noChangeAspect="1"/>
           </p:cNvPicPr>
@@ -6169,8 +6304,8 @@
         </p:blipFill>
         <p:spPr>
           <a:xfrm>
-            <a:off x="6035040" y="1463040"/>
-            <a:ext cx="5394960" cy="3308854"/>
+            <a:off x="6181344" y="2312251"/>
+            <a:ext cx="5132527" cy="3147897"/>
           </a:xfrm>
           <a:prstGeom prst="rect">
             <a:avLst/>
@@ -6406,9 +6541,54 @@
           </a:p>
         </p:txBody>
       </p:sp>
+      <p:sp>
+        <p:nvSpPr>
+          <p:cNvPr id="6" name="Rounded Rectangle 5"/>
+          <p:cNvSpPr/>
+          <p:nvPr/>
+        </p:nvSpPr>
+        <p:spPr>
+          <a:xfrm>
+            <a:off x="4297680" y="1463040"/>
+            <a:ext cx="7162495" cy="4846320"/>
+          </a:xfrm>
+          <a:prstGeom prst="roundRect">
+            <a:avLst/>
+          </a:prstGeom>
+          <a:solidFill>
+            <a:srgbClr val="FFFFFF"/>
+          </a:solidFill>
+          <a:ln w="19050">
+            <a:solidFill>
+              <a:srgbClr val="E2E8F0"/>
+            </a:solidFill>
+          </a:ln>
+        </p:spPr>
+        <p:style>
+          <a:lnRef idx="1">
+            <a:schemeClr val="accent1"/>
+          </a:lnRef>
+          <a:fillRef idx="3">
+            <a:schemeClr val="accent1"/>
+          </a:fillRef>
+          <a:effectRef idx="2">
+            <a:schemeClr val="accent1"/>
+          </a:effectRef>
+          <a:fontRef idx="minor">
+            <a:schemeClr val="lt1"/>
+          </a:fontRef>
+        </p:style>
+        <p:txBody>
+          <a:bodyPr rtlCol="0" anchor="ctr"/>
+          <a:lstStyle/>
+          <a:p>
+            <a:pPr algn="ctr"/>
+          </a:p>
+        </p:txBody>
+      </p:sp>
       <p:pic>
         <p:nvPicPr>
-          <p:cNvPr id="6" name="Picture 5" descr="excel_country_shift.png"/>
+          <p:cNvPr id="7" name="Picture 6" descr="excel_country_shift.png"/>
           <p:cNvPicPr>
             <a:picLocks noChangeAspect="1"/>
           </p:cNvPicPr>
@@ -6422,8 +6602,8 @@
         </p:blipFill>
         <p:spPr>
           <a:xfrm>
-            <a:off x="4297680" y="1463040"/>
-            <a:ext cx="7162495" cy="4638568"/>
+            <a:off x="4443984" y="1661665"/>
+            <a:ext cx="6869887" cy="4449069"/>
           </a:xfrm>
           <a:prstGeom prst="rect">
             <a:avLst/>
@@ -6546,9 +6726,54 @@
           </a:p>
         </p:txBody>
       </p:sp>
+      <p:sp>
+        <p:nvSpPr>
+          <p:cNvPr id="4" name="Rounded Rectangle 3"/>
+          <p:cNvSpPr/>
+          <p:nvPr/>
+        </p:nvSpPr>
+        <p:spPr>
+          <a:xfrm>
+            <a:off x="731520" y="1463040"/>
+            <a:ext cx="5212080" cy="4846320"/>
+          </a:xfrm>
+          <a:prstGeom prst="roundRect">
+            <a:avLst/>
+          </a:prstGeom>
+          <a:solidFill>
+            <a:srgbClr val="FFFFFF"/>
+          </a:solidFill>
+          <a:ln w="19050">
+            <a:solidFill>
+              <a:srgbClr val="2563EB"/>
+            </a:solidFill>
+          </a:ln>
+        </p:spPr>
+        <p:style>
+          <a:lnRef idx="1">
+            <a:schemeClr val="accent1"/>
+          </a:lnRef>
+          <a:fillRef idx="3">
+            <a:schemeClr val="accent1"/>
+          </a:fillRef>
+          <a:effectRef idx="2">
+            <a:schemeClr val="accent1"/>
+          </a:effectRef>
+          <a:fontRef idx="minor">
+            <a:schemeClr val="lt1"/>
+          </a:fontRef>
+        </p:style>
+        <p:txBody>
+          <a:bodyPr rtlCol="0" anchor="ctr"/>
+          <a:lstStyle/>
+          <a:p>
+            <a:pPr algn="ctr"/>
+          </a:p>
+        </p:txBody>
+      </p:sp>
       <p:pic>
         <p:nvPicPr>
-          <p:cNvPr id="4" name="Picture 3" descr="demo_app_overview.png"/>
+          <p:cNvPr id="5" name="Picture 4" descr="demo_app_overview.png"/>
           <p:cNvPicPr>
             <a:picLocks noChangeAspect="1"/>
           </p:cNvPicPr>
@@ -6562,8 +6787,8 @@
         </p:blipFill>
         <p:spPr>
           <a:xfrm>
-            <a:off x="731520" y="1463040"/>
-            <a:ext cx="5212080" cy="3405226"/>
+            <a:off x="868680" y="2273198"/>
+            <a:ext cx="4937760" cy="3226003"/>
           </a:xfrm>
           <a:prstGeom prst="rect">
             <a:avLst/>
@@ -6572,7 +6797,7 @@
       </p:pic>
       <p:sp>
         <p:nvSpPr>
-          <p:cNvPr id="5" name="Rounded Rectangle 4"/>
+          <p:cNvPr id="6" name="Rounded Rectangle 5"/>
           <p:cNvSpPr/>
           <p:nvPr/>
         </p:nvSpPr>
@@ -6617,7 +6842,7 @@
       </p:sp>
       <p:sp>
         <p:nvSpPr>
-          <p:cNvPr id="6" name="TextBox 5"/>
+          <p:cNvPr id="7" name="TextBox 6"/>
           <p:cNvSpPr txBox="1"/>
           <p:nvPr/>
         </p:nvSpPr>
@@ -9724,9 +9949,54 @@
           </a:p>
         </p:txBody>
       </p:sp>
+      <p:sp>
+        <p:nvSpPr>
+          <p:cNvPr id="6" name="Rounded Rectangle 5"/>
+          <p:cNvSpPr/>
+          <p:nvPr/>
+        </p:nvSpPr>
+        <p:spPr>
+          <a:xfrm>
+            <a:off x="4846320" y="1463040"/>
+            <a:ext cx="6613855" cy="4846320"/>
+          </a:xfrm>
+          <a:prstGeom prst="roundRect">
+            <a:avLst/>
+          </a:prstGeom>
+          <a:solidFill>
+            <a:srgbClr val="FFFFFF"/>
+          </a:solidFill>
+          <a:ln w="19050">
+            <a:solidFill>
+              <a:srgbClr val="0284C7"/>
+            </a:solidFill>
+          </a:ln>
+        </p:spPr>
+        <p:style>
+          <a:lnRef idx="1">
+            <a:schemeClr val="accent1"/>
+          </a:lnRef>
+          <a:fillRef idx="3">
+            <a:schemeClr val="accent1"/>
+          </a:fillRef>
+          <a:effectRef idx="2">
+            <a:schemeClr val="accent1"/>
+          </a:effectRef>
+          <a:fontRef idx="minor">
+            <a:schemeClr val="lt1"/>
+          </a:fontRef>
+        </p:style>
+        <p:txBody>
+          <a:bodyPr rtlCol="0" anchor="ctr"/>
+          <a:lstStyle/>
+          <a:p>
+            <a:pPr algn="ctr"/>
+          </a:p>
+        </p:txBody>
+      </p:sp>
       <p:pic>
         <p:nvPicPr>
-          <p:cNvPr id="6" name="Picture 5" descr="pipeline_preprocessing_flow.png"/>
+          <p:cNvPr id="7" name="Picture 6" descr="pipeline_preprocessing_flow.png"/>
           <p:cNvPicPr>
             <a:picLocks noChangeAspect="1"/>
           </p:cNvPicPr>
@@ -9740,8 +10010,8 @@
         </p:blipFill>
         <p:spPr>
           <a:xfrm>
-            <a:off x="4846320" y="1463040"/>
-            <a:ext cx="6613855" cy="4409237"/>
+            <a:off x="4983479" y="1773021"/>
+            <a:ext cx="6339535" cy="4226356"/>
           </a:xfrm>
           <a:prstGeom prst="rect">
             <a:avLst/>
@@ -10090,9 +10360,54 @@
           </a:p>
         </p:txBody>
       </p:sp>
+      <p:sp>
+        <p:nvSpPr>
+          <p:cNvPr id="8" name="Rounded Rectangle 7"/>
+          <p:cNvSpPr/>
+          <p:nvPr/>
+        </p:nvSpPr>
+        <p:spPr>
+          <a:xfrm>
+            <a:off x="4297680" y="1463040"/>
+            <a:ext cx="7162495" cy="4846320"/>
+          </a:xfrm>
+          <a:prstGeom prst="roundRect">
+            <a:avLst/>
+          </a:prstGeom>
+          <a:solidFill>
+            <a:srgbClr val="FFFFFF"/>
+          </a:solidFill>
+          <a:ln w="19050">
+            <a:solidFill>
+              <a:srgbClr val="0284C7"/>
+            </a:solidFill>
+          </a:ln>
+        </p:spPr>
+        <p:style>
+          <a:lnRef idx="1">
+            <a:schemeClr val="accent1"/>
+          </a:lnRef>
+          <a:fillRef idx="3">
+            <a:schemeClr val="accent1"/>
+          </a:fillRef>
+          <a:effectRef idx="2">
+            <a:schemeClr val="accent1"/>
+          </a:effectRef>
+          <a:fontRef idx="minor">
+            <a:schemeClr val="lt1"/>
+          </a:fontRef>
+        </p:style>
+        <p:txBody>
+          <a:bodyPr rtlCol="0" anchor="ctr"/>
+          <a:lstStyle/>
+          <a:p>
+            <a:pPr algn="ctr"/>
+          </a:p>
+        </p:txBody>
+      </p:sp>
       <p:pic>
         <p:nvPicPr>
-          <p:cNvPr id="8" name="Picture 7" descr="nb01_data_cleaning_head.png"/>
+          <p:cNvPr id="9" name="Picture 8" descr="nb01_data_cleaning_head.png"/>
           <p:cNvPicPr>
             <a:picLocks noChangeAspect="1"/>
           </p:cNvPicPr>
@@ -10106,8 +10421,8 @@
         </p:blipFill>
         <p:spPr>
           <a:xfrm>
-            <a:off x="4297680" y="1463040"/>
-            <a:ext cx="7162495" cy="4638568"/>
+            <a:off x="4443984" y="1661665"/>
+            <a:ext cx="6869887" cy="4449069"/>
           </a:xfrm>
           <a:prstGeom prst="rect">
             <a:avLst/>
@@ -10387,9 +10702,54 @@
           </a:p>
         </p:txBody>
       </p:sp>
+      <p:sp>
+        <p:nvSpPr>
+          <p:cNvPr id="6" name="Rounded Rectangle 5"/>
+          <p:cNvSpPr/>
+          <p:nvPr/>
+        </p:nvSpPr>
+        <p:spPr>
+          <a:xfrm>
+            <a:off x="6035040" y="1463040"/>
+            <a:ext cx="5425135" cy="4846320"/>
+          </a:xfrm>
+          <a:prstGeom prst="roundRect">
+            <a:avLst/>
+          </a:prstGeom>
+          <a:solidFill>
+            <a:srgbClr val="FFFFFF"/>
+          </a:solidFill>
+          <a:ln w="19050">
+            <a:solidFill>
+              <a:srgbClr val="2563EB"/>
+            </a:solidFill>
+          </a:ln>
+        </p:spPr>
+        <p:style>
+          <a:lnRef idx="1">
+            <a:schemeClr val="accent1"/>
+          </a:lnRef>
+          <a:fillRef idx="3">
+            <a:schemeClr val="accent1"/>
+          </a:fillRef>
+          <a:effectRef idx="2">
+            <a:schemeClr val="accent1"/>
+          </a:effectRef>
+          <a:fontRef idx="minor">
+            <a:schemeClr val="lt1"/>
+          </a:fontRef>
+        </p:style>
+        <p:txBody>
+          <a:bodyPr rtlCol="0" anchor="ctr"/>
+          <a:lstStyle/>
+          <a:p>
+            <a:pPr algn="ctr"/>
+          </a:p>
+        </p:txBody>
+      </p:sp>
       <p:pic>
         <p:nvPicPr>
-          <p:cNvPr id="6" name="Picture 5" descr="correlation_heatmap.png"/>
+          <p:cNvPr id="7" name="Picture 6" descr="correlation_heatmap.png"/>
           <p:cNvPicPr>
             <a:picLocks noChangeAspect="1"/>
           </p:cNvPicPr>
@@ -10403,8 +10763,8 @@
         </p:blipFill>
         <p:spPr>
           <a:xfrm>
-            <a:off x="6035040" y="1463040"/>
-            <a:ext cx="5394960" cy="4836373"/>
+            <a:off x="6197581" y="1600200"/>
+            <a:ext cx="5100052" cy="4572000"/>
           </a:xfrm>
           <a:prstGeom prst="rect">
             <a:avLst/>
@@ -10684,9 +11044,54 @@
           </a:p>
         </p:txBody>
       </p:sp>
+      <p:sp>
+        <p:nvSpPr>
+          <p:cNvPr id="6" name="Rounded Rectangle 5"/>
+          <p:cNvSpPr/>
+          <p:nvPr/>
+        </p:nvSpPr>
+        <p:spPr>
+          <a:xfrm>
+            <a:off x="4846320" y="1463040"/>
+            <a:ext cx="6613855" cy="4846320"/>
+          </a:xfrm>
+          <a:prstGeom prst="roundRect">
+            <a:avLst/>
+          </a:prstGeom>
+          <a:solidFill>
+            <a:srgbClr val="FFFFFF"/>
+          </a:solidFill>
+          <a:ln w="19050">
+            <a:solidFill>
+              <a:srgbClr val="059669"/>
+            </a:solidFill>
+          </a:ln>
+        </p:spPr>
+        <p:style>
+          <a:lnRef idx="1">
+            <a:schemeClr val="accent1"/>
+          </a:lnRef>
+          <a:fillRef idx="3">
+            <a:schemeClr val="accent1"/>
+          </a:fillRef>
+          <a:effectRef idx="2">
+            <a:schemeClr val="accent1"/>
+          </a:effectRef>
+          <a:fontRef idx="minor">
+            <a:schemeClr val="lt1"/>
+          </a:fontRef>
+        </p:style>
+        <p:txBody>
+          <a:bodyPr rtlCol="0" anchor="ctr"/>
+          <a:lstStyle/>
+          <a:p>
+            <a:pPr algn="ctr"/>
+          </a:p>
+        </p:txBody>
+      </p:sp>
       <p:pic>
         <p:nvPicPr>
-          <p:cNvPr id="6" name="Picture 5" descr="nb03_from_scratch_code.png"/>
+          <p:cNvPr id="7" name="Picture 6" descr="nb03_from_scratch_code.png"/>
           <p:cNvPicPr>
             <a:picLocks noChangeAspect="1"/>
           </p:cNvPicPr>
@@ -10700,8 +11105,8 @@
         </p:blipFill>
         <p:spPr>
           <a:xfrm>
-            <a:off x="4846320" y="1463040"/>
-            <a:ext cx="6613855" cy="4283258"/>
+            <a:off x="4992624" y="1839320"/>
+            <a:ext cx="6321247" cy="4093759"/>
           </a:xfrm>
           <a:prstGeom prst="rect">
             <a:avLst/>
@@ -10824,9 +11229,54 @@
           </a:p>
         </p:txBody>
       </p:sp>
+      <p:sp>
+        <p:nvSpPr>
+          <p:cNvPr id="4" name="Rounded Rectangle 3"/>
+          <p:cNvSpPr/>
+          <p:nvPr/>
+        </p:nvSpPr>
+        <p:spPr>
+          <a:xfrm>
+            <a:off x="731520" y="1463040"/>
+            <a:ext cx="4754880" cy="2148840"/>
+          </a:xfrm>
+          <a:prstGeom prst="roundRect">
+            <a:avLst/>
+          </a:prstGeom>
+          <a:solidFill>
+            <a:srgbClr val="FFFFFF"/>
+          </a:solidFill>
+          <a:ln w="19050">
+            <a:solidFill>
+              <a:srgbClr val="0284C7"/>
+            </a:solidFill>
+          </a:ln>
+        </p:spPr>
+        <p:style>
+          <a:lnRef idx="1">
+            <a:schemeClr val="accent1"/>
+          </a:lnRef>
+          <a:fillRef idx="3">
+            <a:schemeClr val="accent1"/>
+          </a:fillRef>
+          <a:effectRef idx="2">
+            <a:schemeClr val="accent1"/>
+          </a:effectRef>
+          <a:fontRef idx="minor">
+            <a:schemeClr val="lt1"/>
+          </a:fontRef>
+        </p:style>
+        <p:txBody>
+          <a:bodyPr rtlCol="0" anchor="ctr"/>
+          <a:lstStyle/>
+          <a:p>
+            <a:pPr algn="ctr"/>
+          </a:p>
+        </p:txBody>
+      </p:sp>
       <p:pic>
         <p:nvPicPr>
-          <p:cNvPr id="4" name="Picture 3" descr="elbow_silhouette_kmeans.png"/>
+          <p:cNvPr id="5" name="Picture 4" descr="elbow_silhouette_kmeans.png"/>
           <p:cNvPicPr>
             <a:picLocks noChangeAspect="1"/>
           </p:cNvPicPr>
@@ -10840,8 +11290,8 @@
         </p:blipFill>
         <p:spPr>
           <a:xfrm>
-            <a:off x="731520" y="1463040"/>
-            <a:ext cx="4754880" cy="1679601"/>
+            <a:off x="841248" y="1736419"/>
+            <a:ext cx="4535424" cy="1602081"/>
           </a:xfrm>
           <a:prstGeom prst="rect">
             <a:avLst/>
@@ -10850,14 +11300,14 @@
       </p:pic>
       <p:sp>
         <p:nvSpPr>
-          <p:cNvPr id="5" name="Rounded Rectangle 4"/>
+          <p:cNvPr id="6" name="Rounded Rectangle 5"/>
           <p:cNvSpPr/>
           <p:nvPr/>
         </p:nvSpPr>
         <p:spPr>
           <a:xfrm>
-            <a:off x="731520" y="3566160"/>
-            <a:ext cx="4754880" cy="2743200"/>
+            <a:off x="731520" y="3749039"/>
+            <a:ext cx="4754880" cy="2560320"/>
           </a:xfrm>
           <a:prstGeom prst="roundRect">
             <a:avLst/>
@@ -10895,14 +11345,14 @@
       </p:sp>
       <p:sp>
         <p:nvSpPr>
-          <p:cNvPr id="6" name="TextBox 5"/>
+          <p:cNvPr id="7" name="TextBox 6"/>
           <p:cNvSpPr txBox="1"/>
           <p:nvPr/>
         </p:nvSpPr>
         <p:spPr>
           <a:xfrm>
-            <a:off x="932688" y="3566160"/>
-            <a:ext cx="4352544" cy="2743200"/>
+            <a:off x="932688" y="3749039"/>
+            <a:ext cx="4352544" cy="2560320"/>
           </a:xfrm>
           <a:prstGeom prst="rect">
             <a:avLst/>
@@ -10916,7 +11366,7 @@
           <a:lstStyle/>
           <a:p>
             <a:pPr>
-              <a:defRPr sz="1750" b="1">
+              <a:defRPr sz="1700" b="1">
                 <a:solidFill>
                   <a:srgbClr val="0284C7"/>
                 </a:solidFill>
@@ -10930,12 +11380,12 @@
           <a:p>
             <a:pPr>
               <a:spcBef>
-                <a:spcPts val="400"/>
+                <a:spcPts val="300"/>
               </a:spcBef>
               <a:spcAft>
                 <a:spcPts val="0"/>
               </a:spcAft>
-              <a:defRPr sz="1500">
+              <a:defRPr sz="1450">
                 <a:solidFill>
                   <a:srgbClr val="0F172A"/>
                 </a:solidFill>
@@ -10949,12 +11399,12 @@
           <a:p>
             <a:pPr>
               <a:spcBef>
-                <a:spcPts val="400"/>
+                <a:spcPts val="300"/>
               </a:spcBef>
               <a:spcAft>
                 <a:spcPts val="0"/>
               </a:spcAft>
-              <a:defRPr sz="1500">
+              <a:defRPr sz="1450">
                 <a:solidFill>
                   <a:srgbClr val="0F172A"/>
                 </a:solidFill>
@@ -10968,12 +11418,12 @@
           <a:p>
             <a:pPr>
               <a:spcBef>
-                <a:spcPts val="400"/>
+                <a:spcPts val="300"/>
               </a:spcBef>
               <a:spcAft>
                 <a:spcPts val="0"/>
               </a:spcAft>
-              <a:defRPr sz="1500">
+              <a:defRPr sz="1450">
                 <a:solidFill>
                   <a:srgbClr val="0F172A"/>
                 </a:solidFill>
@@ -10987,12 +11437,12 @@
           <a:p>
             <a:pPr>
               <a:spcBef>
-                <a:spcPts val="400"/>
+                <a:spcPts val="300"/>
               </a:spcBef>
               <a:spcAft>
                 <a:spcPts val="0"/>
               </a:spcAft>
-              <a:defRPr sz="1500">
+              <a:defRPr sz="1450">
                 <a:solidFill>
                   <a:srgbClr val="0F172A"/>
                 </a:solidFill>
@@ -11002,12 +11452,57 @@
             <a:r>
               <a:t>• Số cụm phản ánh hoàn hảo 3 nhóm trình độ kinh tế - xã hội.</a:t>
             </a:r>
+          </a:p>
+        </p:txBody>
+      </p:sp>
+      <p:sp>
+        <p:nvSpPr>
+          <p:cNvPr id="8" name="Rounded Rectangle 7"/>
+          <p:cNvSpPr/>
+          <p:nvPr/>
+        </p:nvSpPr>
+        <p:spPr>
+          <a:xfrm>
+            <a:off x="5669280" y="1463040"/>
+            <a:ext cx="5790895" cy="4846320"/>
+          </a:xfrm>
+          <a:prstGeom prst="roundRect">
+            <a:avLst/>
+          </a:prstGeom>
+          <a:solidFill>
+            <a:srgbClr val="FFFFFF"/>
+          </a:solidFill>
+          <a:ln w="19050">
+            <a:solidFill>
+              <a:srgbClr val="0284C7"/>
+            </a:solidFill>
+          </a:ln>
+        </p:spPr>
+        <p:style>
+          <a:lnRef idx="1">
+            <a:schemeClr val="accent1"/>
+          </a:lnRef>
+          <a:fillRef idx="3">
+            <a:schemeClr val="accent1"/>
+          </a:fillRef>
+          <a:effectRef idx="2">
+            <a:schemeClr val="accent1"/>
+          </a:effectRef>
+          <a:fontRef idx="minor">
+            <a:schemeClr val="lt1"/>
+          </a:fontRef>
+        </p:style>
+        <p:txBody>
+          <a:bodyPr rtlCol="0" anchor="ctr"/>
+          <a:lstStyle/>
+          <a:p>
+            <a:pPr algn="ctr"/>
           </a:p>
         </p:txBody>
       </p:sp>
       <p:pic>
         <p:nvPicPr>
-          <p:cNvPr id="7" name="Picture 6" descr="excel_k_sensitivity.png"/>
+          <p:cNvPr id="9" name="Picture 8" descr="excel_k_sensitivity.png"/>
           <p:cNvPicPr>
             <a:picLocks noChangeAspect="1"/>
           </p:cNvPicPr>
@@ -11021,8 +11516,8 @@
         </p:blipFill>
         <p:spPr>
           <a:xfrm>
-            <a:off x="5669280" y="1463040"/>
-            <a:ext cx="5790895" cy="3750294"/>
+            <a:off x="5815584" y="2105802"/>
+            <a:ext cx="5498287" cy="3560795"/>
           </a:xfrm>
           <a:prstGeom prst="rect">
             <a:avLst/>
@@ -11302,9 +11797,54 @@
           </a:p>
         </p:txBody>
       </p:sp>
+      <p:sp>
+        <p:nvSpPr>
+          <p:cNvPr id="6" name="Rounded Rectangle 5"/>
+          <p:cNvSpPr/>
+          <p:nvPr/>
+        </p:nvSpPr>
+        <p:spPr>
+          <a:xfrm>
+            <a:off x="4846320" y="1463040"/>
+            <a:ext cx="6613855" cy="4846320"/>
+          </a:xfrm>
+          <a:prstGeom prst="roundRect">
+            <a:avLst/>
+          </a:prstGeom>
+          <a:solidFill>
+            <a:srgbClr val="FFFFFF"/>
+          </a:solidFill>
+          <a:ln w="19050">
+            <a:solidFill>
+              <a:srgbClr val="0284C7"/>
+            </a:solidFill>
+          </a:ln>
+        </p:spPr>
+        <p:style>
+          <a:lnRef idx="1">
+            <a:schemeClr val="accent1"/>
+          </a:lnRef>
+          <a:fillRef idx="3">
+            <a:schemeClr val="accent1"/>
+          </a:fillRef>
+          <a:effectRef idx="2">
+            <a:schemeClr val="accent1"/>
+          </a:effectRef>
+          <a:fontRef idx="minor">
+            <a:schemeClr val="lt1"/>
+          </a:fontRef>
+        </p:style>
+        <p:txBody>
+          <a:bodyPr rtlCol="0" anchor="ctr"/>
+          <a:lstStyle/>
+          <a:p>
+            <a:pPr algn="ctr"/>
+          </a:p>
+        </p:txBody>
+      </p:sp>
       <p:pic>
         <p:nvPicPr>
-          <p:cNvPr id="6" name="Picture 5" descr="excel_model_comparison.png"/>
+          <p:cNvPr id="7" name="Picture 6" descr="excel_model_comparison.png"/>
           <p:cNvPicPr>
             <a:picLocks noChangeAspect="1"/>
           </p:cNvPicPr>
@@ -11318,8 +11858,8 @@
         </p:blipFill>
         <p:spPr>
           <a:xfrm>
-            <a:off x="4846320" y="1463040"/>
-            <a:ext cx="6613855" cy="4283258"/>
+            <a:off x="4992624" y="1839320"/>
+            <a:ext cx="6321247" cy="4093759"/>
           </a:xfrm>
           <a:prstGeom prst="rect">
             <a:avLst/>

</xml_diff>